<commit_message>
Add deployment mode explanations and share stats
</commit_message>
<xml_diff>
--- a/WRC_WAIC_2026_embodied_system012_onepage.pptx
+++ b/WRC_WAIC_2026_embodied_system012_onepage.pptx
@@ -3105,7 +3105,7 @@
         <p:spPr>
           <a:xfrm>
             <a:off x="201168" y="73152"/>
-            <a:ext cx="8869680" cy="292608"/>
+            <a:ext cx="8961120" cy="292608"/>
           </a:xfrm>
           <a:prstGeom prst="rect">
             <a:avLst/>
@@ -3144,7 +3144,7 @@
         <p:spPr>
           <a:xfrm>
             <a:off x="219456" y="384048"/>
-            <a:ext cx="9326880" cy="146304"/>
+            <a:ext cx="9601200" cy="146304"/>
           </a:xfrm>
           <a:prstGeom prst="rect">
             <a:avLst/>
@@ -3169,7 +3169,7 @@
                 </a:solidFill>
                 <a:latin typeface="Microsoft YaHei UI"/>
               </a:rPr>
-              <a:t>按部署方式合并分类；大脑模型、架构与参数合并呈现；只保留模型、算力、部署与频率信息。</a:t>
+              <a:t>按 13 家/项目统计部署方式占比；第一列合并显示定义、优缺点和采用比例。</a:t>
             </a:r>
           </a:p>
         </p:txBody>
@@ -3184,7 +3184,7 @@
         </p:nvGraphicFramePr>
         <p:xfrm>
           <a:off x="164592" y="621792"/>
-          <a:ext cx="11868911" cy="5248647"/>
+          <a:ext cx="11868912" cy="5248647"/>
         </p:xfrm>
         <a:graphic>
           <a:graphicData uri="http://schemas.openxmlformats.org/drawingml/2006/table">
@@ -3193,12 +3193,12 @@
                 <a:tableStyleId>{5C22544A-7EE6-4342-B048-85BDC9FD1C3A}</a:tableStyleId>
               </a:tblPr>
               <a:tblGrid>
-                <a:gridCol w="841248"/>
-                <a:gridCol w="1115568"/>
-                <a:gridCol w="3493008"/>
-                <a:gridCol w="1874519"/>
-                <a:gridCol w="2880360"/>
-                <a:gridCol w="1664208"/>
+                <a:gridCol w="1572768"/>
+                <a:gridCol w="1060704"/>
+                <a:gridCol w="3017520"/>
+                <a:gridCol w="1691640"/>
+                <a:gridCol w="2761488"/>
+                <a:gridCol w="1764792"/>
               </a:tblGrid>
               <a:tr h="310896">
                 <a:tc>
@@ -3220,7 +3220,7 @@
                         </a:spcAft>
                       </a:pPr>
                       <a:r>
-                        <a:rPr sz="600" b="1">
+                        <a:rPr sz="590" b="1">
                           <a:solidFill>
                             <a:srgbClr val="000000"/>
                           </a:solidFill>
@@ -3275,7 +3275,7 @@
                         </a:spcAft>
                       </a:pPr>
                       <a:r>
-                        <a:rPr sz="600" b="1">
+                        <a:rPr sz="590" b="1">
                           <a:solidFill>
                             <a:srgbClr val="000000"/>
                           </a:solidFill>
@@ -3330,7 +3330,7 @@
                         </a:spcAft>
                       </a:pPr>
                       <a:r>
-                        <a:rPr sz="600" b="1">
+                        <a:rPr sz="590" b="1">
                           <a:solidFill>
                             <a:srgbClr val="000000"/>
                           </a:solidFill>
@@ -3385,7 +3385,7 @@
                         </a:spcAft>
                       </a:pPr>
                       <a:r>
-                        <a:rPr sz="600" b="1">
+                        <a:rPr sz="590" b="1">
                           <a:solidFill>
                             <a:srgbClr val="000000"/>
                           </a:solidFill>
@@ -3440,7 +3440,7 @@
                         </a:spcAft>
                       </a:pPr>
                       <a:r>
-                        <a:rPr sz="600" b="1">
+                        <a:rPr sz="590" b="1">
                           <a:solidFill>
                             <a:srgbClr val="000000"/>
                           </a:solidFill>
@@ -3495,7 +3495,7 @@
                         </a:spcAft>
                       </a:pPr>
                       <a:r>
-                        <a:rPr sz="600" b="1">
+                        <a:rPr sz="590" b="1">
                           <a:solidFill>
                             <a:srgbClr val="000000"/>
                           </a:solidFill>
@@ -3540,7 +3540,7 @@
                     </a:bodyPr>
                     <a:lstStyle/>
                     <a:p>
-                      <a:pPr algn="ctr">
+                      <a:pPr algn="l">
                         <a:lnSpc>
                           <a:spcPct val="88000"/>
                         </a:lnSpc>
@@ -3552,13 +3552,13 @@
                         </a:spcAft>
                       </a:pPr>
                       <a:r>
-                        <a:rPr sz="700" b="1">
+                        <a:rPr sz="475" b="0">
                           <a:solidFill>
                             <a:srgbClr val="000000"/>
                           </a:solidFill>
                           <a:latin typeface="Microsoft YaHei UI"/>
                         </a:rPr>
-                        <a:t>纯端侧/本体端侧</a:t>
+                        <a:t>纯端侧/本体端侧：模型或智脑设备主要在机器人本体运行。优点是离线可用、低时延和数据不出端；缺点是受功耗、显存和散热约束。当前 7/13 家，占 53.8%。</a:t>
                       </a:r>
                     </a:p>
                   </a:txBody>
@@ -3607,7 +3607,7 @@
                         </a:spcAft>
                       </a:pPr>
                       <a:r>
-                        <a:rPr sz="475" b="1">
+                        <a:rPr sz="455" b="1">
                           <a:solidFill>
                             <a:srgbClr val="000000"/>
                           </a:solidFill>
@@ -3662,7 +3662,7 @@
                         </a:spcAft>
                       </a:pPr>
                       <a:r>
-                        <a:rPr sz="415" b="0">
+                        <a:rPr sz="401" b="0">
                           <a:solidFill>
                             <a:srgbClr val="000000"/>
                           </a:solidFill>
@@ -3717,7 +3717,7 @@
                         </a:spcAft>
                       </a:pPr>
                       <a:r>
-                        <a:rPr sz="475" b="0">
+                        <a:rPr sz="455" b="0">
                           <a:solidFill>
                             <a:srgbClr val="000000"/>
                           </a:solidFill>
@@ -3772,7 +3772,7 @@
                         </a:spcAft>
                       </a:pPr>
                       <a:r>
-                        <a:rPr sz="415" b="0">
+                        <a:rPr sz="401" b="0">
                           <a:solidFill>
                             <a:srgbClr val="000000"/>
                           </a:solidFill>
@@ -3827,7 +3827,7 @@
                         </a:spcAft>
                       </a:pPr>
                       <a:r>
-                        <a:rPr sz="415" b="0">
+                        <a:rPr sz="401" b="0">
                           <a:solidFill>
                             <a:srgbClr val="000000"/>
                           </a:solidFill>
@@ -3872,7 +3872,7 @@
                     </a:bodyPr>
                     <a:lstStyle/>
                     <a:p>
-                      <a:pPr algn="ctr">
+                      <a:pPr algn="l">
                         <a:lnSpc>
                           <a:spcPct val="88000"/>
                         </a:lnSpc>
@@ -3884,7 +3884,7 @@
                         </a:spcAft>
                       </a:pPr>
                       <a:r>
-                        <a:rPr sz="475" b="1">
+                        <a:rPr sz="455" b="0">
                           <a:solidFill>
                             <a:srgbClr val="000000"/>
                           </a:solidFill>
@@ -3939,7 +3939,7 @@
                         </a:spcAft>
                       </a:pPr>
                       <a:r>
-                        <a:rPr sz="475" b="1">
+                        <a:rPr sz="455" b="1">
                           <a:solidFill>
                             <a:srgbClr val="000000"/>
                           </a:solidFill>
@@ -3994,7 +3994,7 @@
                         </a:spcAft>
                       </a:pPr>
                       <a:r>
-                        <a:rPr sz="445" b="0">
+                        <a:rPr sz="432" b="0">
                           <a:solidFill>
                             <a:srgbClr val="000000"/>
                           </a:solidFill>
@@ -4049,7 +4049,7 @@
                         </a:spcAft>
                       </a:pPr>
                       <a:r>
-                        <a:rPr sz="475" b="0">
+                        <a:rPr sz="455" b="0">
                           <a:solidFill>
                             <a:srgbClr val="000000"/>
                           </a:solidFill>
@@ -4104,7 +4104,7 @@
                         </a:spcAft>
                       </a:pPr>
                       <a:r>
-                        <a:rPr sz="445" b="0">
+                        <a:rPr sz="432" b="0">
                           <a:solidFill>
                             <a:srgbClr val="000000"/>
                           </a:solidFill>
@@ -4159,7 +4159,7 @@
                         </a:spcAft>
                       </a:pPr>
                       <a:r>
-                        <a:rPr sz="445" b="0">
+                        <a:rPr sz="432" b="0">
                           <a:solidFill>
                             <a:srgbClr val="000000"/>
                           </a:solidFill>
@@ -4204,7 +4204,7 @@
                     </a:bodyPr>
                     <a:lstStyle/>
                     <a:p>
-                      <a:pPr algn="ctr">
+                      <a:pPr algn="l">
                         <a:lnSpc>
                           <a:spcPct val="88000"/>
                         </a:lnSpc>
@@ -4216,7 +4216,7 @@
                         </a:spcAft>
                       </a:pPr>
                       <a:r>
-                        <a:rPr sz="475" b="1">
+                        <a:rPr sz="455" b="0">
                           <a:solidFill>
                             <a:srgbClr val="000000"/>
                           </a:solidFill>
@@ -4271,7 +4271,7 @@
                         </a:spcAft>
                       </a:pPr>
                       <a:r>
-                        <a:rPr sz="475" b="1">
+                        <a:rPr sz="455" b="1">
                           <a:solidFill>
                             <a:srgbClr val="000000"/>
                           </a:solidFill>
@@ -4326,7 +4326,7 @@
                         </a:spcAft>
                       </a:pPr>
                       <a:r>
-                        <a:rPr sz="415" b="0">
+                        <a:rPr sz="401" b="0">
                           <a:solidFill>
                             <a:srgbClr val="000000"/>
                           </a:solidFill>
@@ -4381,7 +4381,7 @@
                         </a:spcAft>
                       </a:pPr>
                       <a:r>
-                        <a:rPr sz="475" b="0">
+                        <a:rPr sz="455" b="0">
                           <a:solidFill>
                             <a:srgbClr val="000000"/>
                           </a:solidFill>
@@ -4436,7 +4436,7 @@
                         </a:spcAft>
                       </a:pPr>
                       <a:r>
-                        <a:rPr sz="415" b="0">
+                        <a:rPr sz="401" b="0">
                           <a:solidFill>
                             <a:srgbClr val="000000"/>
                           </a:solidFill>
@@ -4491,7 +4491,7 @@
                         </a:spcAft>
                       </a:pPr>
                       <a:r>
-                        <a:rPr sz="415" b="0">
+                        <a:rPr sz="401" b="0">
                           <a:solidFill>
                             <a:srgbClr val="000000"/>
                           </a:solidFill>
@@ -4536,7 +4536,7 @@
                     </a:bodyPr>
                     <a:lstStyle/>
                     <a:p>
-                      <a:pPr algn="ctr">
+                      <a:pPr algn="l">
                         <a:lnSpc>
                           <a:spcPct val="88000"/>
                         </a:lnSpc>
@@ -4548,7 +4548,7 @@
                         </a:spcAft>
                       </a:pPr>
                       <a:r>
-                        <a:rPr sz="475" b="1">
+                        <a:rPr sz="455" b="0">
                           <a:solidFill>
                             <a:srgbClr val="000000"/>
                           </a:solidFill>
@@ -4603,7 +4603,7 @@
                         </a:spcAft>
                       </a:pPr>
                       <a:r>
-                        <a:rPr sz="475" b="1">
+                        <a:rPr sz="455" b="1">
                           <a:solidFill>
                             <a:srgbClr val="000000"/>
                           </a:solidFill>
@@ -4658,7 +4658,7 @@
                         </a:spcAft>
                       </a:pPr>
                       <a:r>
-                        <a:rPr sz="445" b="0">
+                        <a:rPr sz="432" b="0">
                           <a:solidFill>
                             <a:srgbClr val="000000"/>
                           </a:solidFill>
@@ -4713,7 +4713,7 @@
                         </a:spcAft>
                       </a:pPr>
                       <a:r>
-                        <a:rPr sz="475" b="0">
+                        <a:rPr sz="455" b="0">
                           <a:solidFill>
                             <a:srgbClr val="000000"/>
                           </a:solidFill>
@@ -4768,7 +4768,7 @@
                         </a:spcAft>
                       </a:pPr>
                       <a:r>
-                        <a:rPr sz="445" b="0">
+                        <a:rPr sz="432" b="0">
                           <a:solidFill>
                             <a:srgbClr val="000000"/>
                           </a:solidFill>
@@ -4823,7 +4823,7 @@
                         </a:spcAft>
                       </a:pPr>
                       <a:r>
-                        <a:rPr sz="445" b="0">
+                        <a:rPr sz="432" b="0">
                           <a:solidFill>
                             <a:srgbClr val="000000"/>
                           </a:solidFill>
@@ -4868,7 +4868,7 @@
                     </a:bodyPr>
                     <a:lstStyle/>
                     <a:p>
-                      <a:pPr algn="ctr">
+                      <a:pPr algn="l">
                         <a:lnSpc>
                           <a:spcPct val="88000"/>
                         </a:lnSpc>
@@ -4880,7 +4880,7 @@
                         </a:spcAft>
                       </a:pPr>
                       <a:r>
-                        <a:rPr sz="475" b="1">
+                        <a:rPr sz="455" b="0">
                           <a:solidFill>
                             <a:srgbClr val="000000"/>
                           </a:solidFill>
@@ -4935,7 +4935,7 @@
                         </a:spcAft>
                       </a:pPr>
                       <a:r>
-                        <a:rPr sz="475" b="1">
+                        <a:rPr sz="455" b="1">
                           <a:solidFill>
                             <a:srgbClr val="000000"/>
                           </a:solidFill>
@@ -4990,7 +4990,7 @@
                         </a:spcAft>
                       </a:pPr>
                       <a:r>
-                        <a:rPr sz="445" b="0">
+                        <a:rPr sz="432" b="0">
                           <a:solidFill>
                             <a:srgbClr val="000000"/>
                           </a:solidFill>
@@ -5045,7 +5045,7 @@
                         </a:spcAft>
                       </a:pPr>
                       <a:r>
-                        <a:rPr sz="475" b="0">
+                        <a:rPr sz="455" b="0">
                           <a:solidFill>
                             <a:srgbClr val="000000"/>
                           </a:solidFill>
@@ -5100,7 +5100,7 @@
                         </a:spcAft>
                       </a:pPr>
                       <a:r>
-                        <a:rPr sz="445" b="0">
+                        <a:rPr sz="432" b="0">
                           <a:solidFill>
                             <a:srgbClr val="000000"/>
                           </a:solidFill>
@@ -5155,7 +5155,7 @@
                         </a:spcAft>
                       </a:pPr>
                       <a:r>
-                        <a:rPr sz="445" b="0">
+                        <a:rPr sz="432" b="0">
                           <a:solidFill>
                             <a:srgbClr val="000000"/>
                           </a:solidFill>
@@ -5200,7 +5200,7 @@
                     </a:bodyPr>
                     <a:lstStyle/>
                     <a:p>
-                      <a:pPr algn="ctr">
+                      <a:pPr algn="l">
                         <a:lnSpc>
                           <a:spcPct val="88000"/>
                         </a:lnSpc>
@@ -5212,7 +5212,7 @@
                         </a:spcAft>
                       </a:pPr>
                       <a:r>
-                        <a:rPr sz="475" b="1">
+                        <a:rPr sz="455" b="0">
                           <a:solidFill>
                             <a:srgbClr val="000000"/>
                           </a:solidFill>
@@ -5267,7 +5267,7 @@
                         </a:spcAft>
                       </a:pPr>
                       <a:r>
-                        <a:rPr sz="475" b="1">
+                        <a:rPr sz="455" b="1">
                           <a:solidFill>
                             <a:srgbClr val="000000"/>
                           </a:solidFill>
@@ -5322,7 +5322,7 @@
                         </a:spcAft>
                       </a:pPr>
                       <a:r>
-                        <a:rPr sz="415" b="0">
+                        <a:rPr sz="401" b="0">
                           <a:solidFill>
                             <a:srgbClr val="000000"/>
                           </a:solidFill>
@@ -5377,7 +5377,7 @@
                         </a:spcAft>
                       </a:pPr>
                       <a:r>
-                        <a:rPr sz="475" b="0">
+                        <a:rPr sz="455" b="0">
                           <a:solidFill>
                             <a:srgbClr val="000000"/>
                           </a:solidFill>
@@ -5432,7 +5432,7 @@
                         </a:spcAft>
                       </a:pPr>
                       <a:r>
-                        <a:rPr sz="415" b="0">
+                        <a:rPr sz="401" b="0">
                           <a:solidFill>
                             <a:srgbClr val="000000"/>
                           </a:solidFill>
@@ -5487,7 +5487,7 @@
                         </a:spcAft>
                       </a:pPr>
                       <a:r>
-                        <a:rPr sz="415" b="0">
+                        <a:rPr sz="401" b="0">
                           <a:solidFill>
                             <a:srgbClr val="000000"/>
                           </a:solidFill>
@@ -5532,7 +5532,7 @@
                     </a:bodyPr>
                     <a:lstStyle/>
                     <a:p>
-                      <a:pPr algn="ctr">
+                      <a:pPr algn="l">
                         <a:lnSpc>
                           <a:spcPct val="88000"/>
                         </a:lnSpc>
@@ -5544,7 +5544,7 @@
                         </a:spcAft>
                       </a:pPr>
                       <a:r>
-                        <a:rPr sz="475" b="1">
+                        <a:rPr sz="455" b="0">
                           <a:solidFill>
                             <a:srgbClr val="000000"/>
                           </a:solidFill>
@@ -5599,7 +5599,7 @@
                         </a:spcAft>
                       </a:pPr>
                       <a:r>
-                        <a:rPr sz="475" b="1">
+                        <a:rPr sz="455" b="1">
                           <a:solidFill>
                             <a:srgbClr val="000000"/>
                           </a:solidFill>
@@ -5654,7 +5654,7 @@
                         </a:spcAft>
                       </a:pPr>
                       <a:r>
-                        <a:rPr sz="445" b="0">
+                        <a:rPr sz="432" b="0">
                           <a:solidFill>
                             <a:srgbClr val="000000"/>
                           </a:solidFill>
@@ -5709,7 +5709,7 @@
                         </a:spcAft>
                       </a:pPr>
                       <a:r>
-                        <a:rPr sz="475" b="0">
+                        <a:rPr sz="455" b="0">
                           <a:solidFill>
                             <a:srgbClr val="000000"/>
                           </a:solidFill>
@@ -5764,7 +5764,7 @@
                         </a:spcAft>
                       </a:pPr>
                       <a:r>
-                        <a:rPr sz="445" b="0">
+                        <a:rPr sz="432" b="0">
                           <a:solidFill>
                             <a:srgbClr val="000000"/>
                           </a:solidFill>
@@ -5819,7 +5819,7 @@
                         </a:spcAft>
                       </a:pPr>
                       <a:r>
-                        <a:rPr sz="445" b="0">
+                        <a:rPr sz="432" b="0">
                           <a:solidFill>
                             <a:srgbClr val="000000"/>
                           </a:solidFill>
@@ -5864,7 +5864,7 @@
                     </a:bodyPr>
                     <a:lstStyle/>
                     <a:p>
-                      <a:pPr algn="ctr">
+                      <a:pPr algn="l">
                         <a:lnSpc>
                           <a:spcPct val="88000"/>
                         </a:lnSpc>
@@ -5876,13 +5876,13 @@
                         </a:spcAft>
                       </a:pPr>
                       <a:r>
-                        <a:rPr sz="700" b="1">
+                        <a:rPr sz="475" b="0">
                           <a:solidFill>
                             <a:srgbClr val="000000"/>
                           </a:solidFill>
                           <a:latin typeface="Microsoft YaHei UI"/>
                         </a:rPr>
-                        <a:t>端云协同</a:t>
+                        <a:t>端云协同：端侧处理高实时能力，云侧处理慢推理和多机调度。优点是兼顾低延迟和更强模型；缺点是依赖网络与系统编排。当前 3/13 家，占 23.1%。</a:t>
                       </a:r>
                     </a:p>
                   </a:txBody>
@@ -5931,7 +5931,7 @@
                         </a:spcAft>
                       </a:pPr>
                       <a:r>
-                        <a:rPr sz="475" b="1">
+                        <a:rPr sz="455" b="1">
                           <a:solidFill>
                             <a:srgbClr val="000000"/>
                           </a:solidFill>
@@ -5986,7 +5986,7 @@
                         </a:spcAft>
                       </a:pPr>
                       <a:r>
-                        <a:rPr sz="445" b="0">
+                        <a:rPr sz="432" b="0">
                           <a:solidFill>
                             <a:srgbClr val="000000"/>
                           </a:solidFill>
@@ -6041,7 +6041,7 @@
                         </a:spcAft>
                       </a:pPr>
                       <a:r>
-                        <a:rPr sz="475" b="0">
+                        <a:rPr sz="455" b="0">
                           <a:solidFill>
                             <a:srgbClr val="000000"/>
                           </a:solidFill>
@@ -6096,7 +6096,7 @@
                         </a:spcAft>
                       </a:pPr>
                       <a:r>
-                        <a:rPr sz="445" b="0">
+                        <a:rPr sz="432" b="0">
                           <a:solidFill>
                             <a:srgbClr val="000000"/>
                           </a:solidFill>
@@ -6151,7 +6151,7 @@
                         </a:spcAft>
                       </a:pPr>
                       <a:r>
-                        <a:rPr sz="445" b="0">
+                        <a:rPr sz="432" b="0">
                           <a:solidFill>
                             <a:srgbClr val="000000"/>
                           </a:solidFill>
@@ -6196,7 +6196,7 @@
                     </a:bodyPr>
                     <a:lstStyle/>
                     <a:p>
-                      <a:pPr algn="ctr">
+                      <a:pPr algn="l">
                         <a:lnSpc>
                           <a:spcPct val="88000"/>
                         </a:lnSpc>
@@ -6208,7 +6208,7 @@
                         </a:spcAft>
                       </a:pPr>
                       <a:r>
-                        <a:rPr sz="475" b="1">
+                        <a:rPr sz="455" b="0">
                           <a:solidFill>
                             <a:srgbClr val="000000"/>
                           </a:solidFill>
@@ -6263,7 +6263,7 @@
                         </a:spcAft>
                       </a:pPr>
                       <a:r>
-                        <a:rPr sz="475" b="1">
+                        <a:rPr sz="455" b="1">
                           <a:solidFill>
                             <a:srgbClr val="000000"/>
                           </a:solidFill>
@@ -6318,7 +6318,7 @@
                         </a:spcAft>
                       </a:pPr>
                       <a:r>
-                        <a:rPr sz="445" b="0">
+                        <a:rPr sz="432" b="0">
                           <a:solidFill>
                             <a:srgbClr val="000000"/>
                           </a:solidFill>
@@ -6373,7 +6373,7 @@
                         </a:spcAft>
                       </a:pPr>
                       <a:r>
-                        <a:rPr sz="475" b="0">
+                        <a:rPr sz="455" b="0">
                           <a:solidFill>
                             <a:srgbClr val="000000"/>
                           </a:solidFill>
@@ -6428,7 +6428,7 @@
                         </a:spcAft>
                       </a:pPr>
                       <a:r>
-                        <a:rPr sz="445" b="0">
+                        <a:rPr sz="432" b="0">
                           <a:solidFill>
                             <a:srgbClr val="000000"/>
                           </a:solidFill>
@@ -6483,7 +6483,7 @@
                         </a:spcAft>
                       </a:pPr>
                       <a:r>
-                        <a:rPr sz="445" b="0">
+                        <a:rPr sz="432" b="0">
                           <a:solidFill>
                             <a:srgbClr val="000000"/>
                           </a:solidFill>
@@ -6528,7 +6528,7 @@
                     </a:bodyPr>
                     <a:lstStyle/>
                     <a:p>
-                      <a:pPr algn="ctr">
+                      <a:pPr algn="l">
                         <a:lnSpc>
                           <a:spcPct val="88000"/>
                         </a:lnSpc>
@@ -6540,7 +6540,7 @@
                         </a:spcAft>
                       </a:pPr>
                       <a:r>
-                        <a:rPr sz="475" b="1">
+                        <a:rPr sz="455" b="0">
                           <a:solidFill>
                             <a:srgbClr val="000000"/>
                           </a:solidFill>
@@ -6595,7 +6595,7 @@
                         </a:spcAft>
                       </a:pPr>
                       <a:r>
-                        <a:rPr sz="475" b="1">
+                        <a:rPr sz="455" b="1">
                           <a:solidFill>
                             <a:srgbClr val="000000"/>
                           </a:solidFill>
@@ -6650,7 +6650,7 @@
                         </a:spcAft>
                       </a:pPr>
                       <a:r>
-                        <a:rPr sz="415" b="0">
+                        <a:rPr sz="401" b="0">
                           <a:solidFill>
                             <a:srgbClr val="000000"/>
                           </a:solidFill>
@@ -6705,7 +6705,7 @@
                         </a:spcAft>
                       </a:pPr>
                       <a:r>
-                        <a:rPr sz="475" b="0">
+                        <a:rPr sz="455" b="0">
                           <a:solidFill>
                             <a:srgbClr val="000000"/>
                           </a:solidFill>
@@ -6760,7 +6760,7 @@
                         </a:spcAft>
                       </a:pPr>
                       <a:r>
-                        <a:rPr sz="415" b="0">
+                        <a:rPr sz="401" b="0">
                           <a:solidFill>
                             <a:srgbClr val="000000"/>
                           </a:solidFill>
@@ -6815,7 +6815,7 @@
                         </a:spcAft>
                       </a:pPr>
                       <a:r>
-                        <a:rPr sz="415" b="0">
+                        <a:rPr sz="401" b="0">
                           <a:solidFill>
                             <a:srgbClr val="000000"/>
                           </a:solidFill>
@@ -6860,7 +6860,7 @@
                     </a:bodyPr>
                     <a:lstStyle/>
                     <a:p>
-                      <a:pPr algn="ctr">
+                      <a:pPr algn="l">
                         <a:lnSpc>
                           <a:spcPct val="88000"/>
                         </a:lnSpc>
@@ -6872,13 +6872,13 @@
                         </a:spcAft>
                       </a:pPr>
                       <a:r>
-                        <a:rPr sz="700" b="1">
+                        <a:rPr sz="475" b="0">
                           <a:solidFill>
                             <a:srgbClr val="000000"/>
                           </a:solidFill>
                           <a:latin typeface="Microsoft YaHei UI"/>
                         </a:rPr>
-                        <a:t>云侧/平台未明</a:t>
+                        <a:t>云侧/平台未明：公开资料未说明生产部署方式，或大脑更像平台/研究模型。优点是模型尺度和训练迭代空间更大；缺点是离线能力与实时性不确定。当前 3/13 家，占 23.1%。</a:t>
                       </a:r>
                     </a:p>
                   </a:txBody>
@@ -6927,7 +6927,7 @@
                         </a:spcAft>
                       </a:pPr>
                       <a:r>
-                        <a:rPr sz="475" b="1">
+                        <a:rPr sz="455" b="1">
                           <a:solidFill>
                             <a:srgbClr val="000000"/>
                           </a:solidFill>
@@ -6982,7 +6982,7 @@
                         </a:spcAft>
                       </a:pPr>
                       <a:r>
-                        <a:rPr sz="415" b="0">
+                        <a:rPr sz="401" b="0">
                           <a:solidFill>
                             <a:srgbClr val="000000"/>
                           </a:solidFill>
@@ -7037,7 +7037,7 @@
                         </a:spcAft>
                       </a:pPr>
                       <a:r>
-                        <a:rPr sz="475" b="0">
+                        <a:rPr sz="455" b="0">
                           <a:solidFill>
                             <a:srgbClr val="000000"/>
                           </a:solidFill>
@@ -7092,7 +7092,7 @@
                         </a:spcAft>
                       </a:pPr>
                       <a:r>
-                        <a:rPr sz="415" b="0">
+                        <a:rPr sz="401" b="0">
                           <a:solidFill>
                             <a:srgbClr val="000000"/>
                           </a:solidFill>
@@ -7147,7 +7147,7 @@
                         </a:spcAft>
                       </a:pPr>
                       <a:r>
-                        <a:rPr sz="415" b="0">
+                        <a:rPr sz="401" b="0">
                           <a:solidFill>
                             <a:srgbClr val="000000"/>
                           </a:solidFill>
@@ -7192,7 +7192,7 @@
                     </a:bodyPr>
                     <a:lstStyle/>
                     <a:p>
-                      <a:pPr algn="ctr">
+                      <a:pPr algn="l">
                         <a:lnSpc>
                           <a:spcPct val="88000"/>
                         </a:lnSpc>
@@ -7204,7 +7204,7 @@
                         </a:spcAft>
                       </a:pPr>
                       <a:r>
-                        <a:rPr sz="475" b="1">
+                        <a:rPr sz="455" b="0">
                           <a:solidFill>
                             <a:srgbClr val="000000"/>
                           </a:solidFill>
@@ -7259,7 +7259,7 @@
                         </a:spcAft>
                       </a:pPr>
                       <a:r>
-                        <a:rPr sz="475" b="1">
+                        <a:rPr sz="455" b="1">
                           <a:solidFill>
                             <a:srgbClr val="000000"/>
                           </a:solidFill>
@@ -7314,7 +7314,7 @@
                         </a:spcAft>
                       </a:pPr>
                       <a:r>
-                        <a:rPr sz="445" b="0">
+                        <a:rPr sz="432" b="0">
                           <a:solidFill>
                             <a:srgbClr val="000000"/>
                           </a:solidFill>
@@ -7369,7 +7369,7 @@
                         </a:spcAft>
                       </a:pPr>
                       <a:r>
-                        <a:rPr sz="475" b="0">
+                        <a:rPr sz="455" b="0">
                           <a:solidFill>
                             <a:srgbClr val="000000"/>
                           </a:solidFill>
@@ -7424,7 +7424,7 @@
                         </a:spcAft>
                       </a:pPr>
                       <a:r>
-                        <a:rPr sz="445" b="0">
+                        <a:rPr sz="432" b="0">
                           <a:solidFill>
                             <a:srgbClr val="000000"/>
                           </a:solidFill>
@@ -7479,7 +7479,7 @@
                         </a:spcAft>
                       </a:pPr>
                       <a:r>
-                        <a:rPr sz="445" b="0">
+                        <a:rPr sz="432" b="0">
                           <a:solidFill>
                             <a:srgbClr val="000000"/>
                           </a:solidFill>
@@ -7524,7 +7524,7 @@
                     </a:bodyPr>
                     <a:lstStyle/>
                     <a:p>
-                      <a:pPr algn="ctr">
+                      <a:pPr algn="l">
                         <a:lnSpc>
                           <a:spcPct val="88000"/>
                         </a:lnSpc>
@@ -7536,7 +7536,7 @@
                         </a:spcAft>
                       </a:pPr>
                       <a:r>
-                        <a:rPr sz="475" b="1">
+                        <a:rPr sz="455" b="0">
                           <a:solidFill>
                             <a:srgbClr val="000000"/>
                           </a:solidFill>
@@ -7591,7 +7591,7 @@
                         </a:spcAft>
                       </a:pPr>
                       <a:r>
-                        <a:rPr sz="475" b="1">
+                        <a:rPr sz="455" b="1">
                           <a:solidFill>
                             <a:srgbClr val="000000"/>
                           </a:solidFill>
@@ -7646,7 +7646,7 @@
                         </a:spcAft>
                       </a:pPr>
                       <a:r>
-                        <a:rPr sz="445" b="0">
+                        <a:rPr sz="432" b="0">
                           <a:solidFill>
                             <a:srgbClr val="000000"/>
                           </a:solidFill>
@@ -7701,7 +7701,7 @@
                         </a:spcAft>
                       </a:pPr>
                       <a:r>
-                        <a:rPr sz="475" b="0">
+                        <a:rPr sz="455" b="0">
                           <a:solidFill>
                             <a:srgbClr val="000000"/>
                           </a:solidFill>
@@ -7756,7 +7756,7 @@
                         </a:spcAft>
                       </a:pPr>
                       <a:r>
-                        <a:rPr sz="445" b="0">
+                        <a:rPr sz="432" b="0">
                           <a:solidFill>
                             <a:srgbClr val="000000"/>
                           </a:solidFill>
@@ -7811,7 +7811,7 @@
                         </a:spcAft>
                       </a:pPr>
                       <a:r>
-                        <a:rPr sz="445" b="0">
+                        <a:rPr sz="432" b="0">
                           <a:solidFill>
                             <a:srgbClr val="000000"/>
                           </a:solidFill>

</xml_diff>